<commit_message>
fix headers in pptx
</commit_message>
<xml_diff>
--- a/tests/report_generator/integration/references/reference_portfolio-baseline-report.pptx
+++ b/tests/report_generator/integration/references/reference_portfolio-baseline-report.pptx
@@ -219,7 +219,7 @@
             <c:invertIfNegative val="0"/>
             <c:bubble3D val="0"/>
             <c:explosion val="6"/>
-            <c:extLst xmlns:lc="http://schemas.openxmlformats.org/drawingml/2006/lockedCanvas" xmlns:comp="http://schemas.openxmlformats.org/drawingml/2006/compatibility" xmlns:we="http://schemas.microsoft.com/office/webextensions/webextension/2010/11" xmlns:wetp="http://schemas.microsoft.com/office/webextensions/taskpanes/2010/11" xmlns:w16cid="http://schemas.microsoft.com/office/word/2016/wordml/cid" xmlns:w16se="http://schemas.microsoft.com/office/word/2015/wordml/symex" xmlns:wps="http://schemas.microsoft.com/office/word/2010/wordprocessingShape" xmlns:b="http://schemas.openxmlformats.org/officeDocument/2006/bibliography" xmlns:odgm="http://opendope.org/SmartArt/DataHierarchy" xmlns:odi="http://opendope.org/components" xmlns:oda="http://opendope.org/answers" xmlns:odq="http://opendope.org/questions" xmlns:odc="http://opendope.org/conditions" xmlns:odx="http://opendope.org/xpaths" xmlns:cppr="http://schemas.microsoft.com/office/2006/coverPageProps" xmlns:pvml="urn:schemas-microsoft-com:office:powerpoint" xmlns:w10="urn:schemas-microsoft-com:office:word" xmlns:v="urn:schemas-microsoft-com:vml" xmlns:o="urn:schemas-microsoft-com:office:office" xmlns:xvml="urn:schemas-microsoft-com:office:excel" xmlns:dsp="http://schemas.microsoft.com/office/drawing/2008/diagram" xmlns:xdr="http://schemas.openxmlformats.org/drawingml/2006/spreadsheetDrawing" xmlns:pic="http://schemas.openxmlformats.org/drawingml/2006/picture" xmlns:dgm="http://schemas.openxmlformats.org/drawingml/2006/diagram" xmlns:c14="http://schemas.microsoft.com/office/drawing/2007/8/2/chart" xmlns:cdr="http://schemas.openxmlformats.org/drawingml/2006/chartDrawing" xmlns:wne="http://schemas.microsoft.com/office/word/2006/wordml" xmlns:sl="http://schemas.openxmlformats.org/schemaLibrary/2006/main" xmlns:mc="http://schemas.openxmlformats.org/markup-compatibility/2006" xmlns:wp14="http://schemas.microsoft.com/office/word/2010/wordprocessingDrawing" xmlns:wp="http://schemas.openxmlformats.org/drawingml/2006/wordprocessingDrawing" xmlns:m="http://schemas.openxmlformats.org/officeDocument/2006/math" xmlns:w14="http://schemas.microsoft.com/office/word/2010/wordml" xmlns:w15="http://schemas.microsoft.com/office/word/2012/wordml" xmlns:w="http://schemas.openxmlformats.org/wordprocessingml/2006/main">
+            <c:extLst xmlns:w="http://schemas.openxmlformats.org/wordprocessingml/2006/main" xmlns:w15="http://schemas.microsoft.com/office/word/2012/wordml" xmlns:w14="http://schemas.microsoft.com/office/word/2010/wordml" xmlns:m="http://schemas.openxmlformats.org/officeDocument/2006/math" xmlns:wp="http://schemas.openxmlformats.org/drawingml/2006/wordprocessingDrawing" xmlns:wp14="http://schemas.microsoft.com/office/word/2010/wordprocessingDrawing" xmlns:mc="http://schemas.openxmlformats.org/markup-compatibility/2006" xmlns:sl="http://schemas.openxmlformats.org/schemaLibrary/2006/main" xmlns:wne="http://schemas.microsoft.com/office/word/2006/wordml" xmlns:cdr="http://schemas.openxmlformats.org/drawingml/2006/chartDrawing" xmlns:c14="http://schemas.microsoft.com/office/drawing/2007/8/2/chart" xmlns:dgm="http://schemas.openxmlformats.org/drawingml/2006/diagram" xmlns:pic="http://schemas.openxmlformats.org/drawingml/2006/picture" xmlns:xdr="http://schemas.openxmlformats.org/drawingml/2006/spreadsheetDrawing" xmlns:dsp="http://schemas.microsoft.com/office/drawing/2008/diagram" xmlns:xvml="urn:schemas-microsoft-com:office:excel" xmlns:o="urn:schemas-microsoft-com:office:office" xmlns:v="urn:schemas-microsoft-com:vml" xmlns:w10="urn:schemas-microsoft-com:office:word" xmlns:pvml="urn:schemas-microsoft-com:office:powerpoint" xmlns:cppr="http://schemas.microsoft.com/office/2006/coverPageProps" xmlns:odx="http://opendope.org/xpaths" xmlns:odc="http://opendope.org/conditions" xmlns:odq="http://opendope.org/questions" xmlns:oda="http://opendope.org/answers" xmlns:odi="http://opendope.org/components" xmlns:odgm="http://opendope.org/SmartArt/DataHierarchy" xmlns:b="http://schemas.openxmlformats.org/officeDocument/2006/bibliography" xmlns:wps="http://schemas.microsoft.com/office/word/2010/wordprocessingShape" xmlns:w16se="http://schemas.microsoft.com/office/word/2015/wordml/symex" xmlns:w16cid="http://schemas.microsoft.com/office/word/2016/wordml/cid" xmlns:wetp="http://schemas.microsoft.com/office/webextensions/taskpanes/2010/11" xmlns:we="http://schemas.microsoft.com/office/webextensions/webextension/2010/11" xmlns:comp="http://schemas.openxmlformats.org/drawingml/2006/compatibility" xmlns:lc="http://schemas.openxmlformats.org/drawingml/2006/lockedCanvas">
               <c:ext xmlns:c16="http://schemas.microsoft.com/office/drawing/2014/chart" uri="{C3380CC4-5D6E-409C-BE32-E72D297353CC}">
                 <c16:uniqueId val="{00000000-7C96-CF4F-94AD-E08A5CD6D25E}"/>
               </c:ext>
@@ -358,7 +358,7 @@
               </c:numCache>
             </c:numRef>
           </c:val>
-          <c:extLst xmlns:lc="http://schemas.openxmlformats.org/drawingml/2006/lockedCanvas" xmlns:comp="http://schemas.openxmlformats.org/drawingml/2006/compatibility" xmlns:we="http://schemas.microsoft.com/office/webextensions/webextension/2010/11" xmlns:wetp="http://schemas.microsoft.com/office/webextensions/taskpanes/2010/11" xmlns:w16cid="http://schemas.microsoft.com/office/word/2016/wordml/cid" xmlns:w16se="http://schemas.microsoft.com/office/word/2015/wordml/symex" xmlns:wps="http://schemas.microsoft.com/office/word/2010/wordprocessingShape" xmlns:b="http://schemas.openxmlformats.org/officeDocument/2006/bibliography" xmlns:odgm="http://opendope.org/SmartArt/DataHierarchy" xmlns:odi="http://opendope.org/components" xmlns:oda="http://opendope.org/answers" xmlns:odq="http://opendope.org/questions" xmlns:odc="http://opendope.org/conditions" xmlns:odx="http://opendope.org/xpaths" xmlns:cppr="http://schemas.microsoft.com/office/2006/coverPageProps" xmlns:pvml="urn:schemas-microsoft-com:office:powerpoint" xmlns:w10="urn:schemas-microsoft-com:office:word" xmlns:v="urn:schemas-microsoft-com:vml" xmlns:o="urn:schemas-microsoft-com:office:office" xmlns:xvml="urn:schemas-microsoft-com:office:excel" xmlns:dsp="http://schemas.microsoft.com/office/drawing/2008/diagram" xmlns:xdr="http://schemas.openxmlformats.org/drawingml/2006/spreadsheetDrawing" xmlns:pic="http://schemas.openxmlformats.org/drawingml/2006/picture" xmlns:dgm="http://schemas.openxmlformats.org/drawingml/2006/diagram" xmlns:c14="http://schemas.microsoft.com/office/drawing/2007/8/2/chart" xmlns:cdr="http://schemas.openxmlformats.org/drawingml/2006/chartDrawing" xmlns:wne="http://schemas.microsoft.com/office/word/2006/wordml" xmlns:sl="http://schemas.openxmlformats.org/schemaLibrary/2006/main" xmlns:mc="http://schemas.openxmlformats.org/markup-compatibility/2006" xmlns:wp14="http://schemas.microsoft.com/office/word/2010/wordprocessingDrawing" xmlns:wp="http://schemas.openxmlformats.org/drawingml/2006/wordprocessingDrawing" xmlns:m="http://schemas.openxmlformats.org/officeDocument/2006/math" xmlns:w14="http://schemas.microsoft.com/office/word/2010/wordml" xmlns:w15="http://schemas.microsoft.com/office/word/2012/wordml" xmlns:w="http://schemas.openxmlformats.org/wordprocessingml/2006/main">
+          <c:extLst xmlns:w="http://schemas.openxmlformats.org/wordprocessingml/2006/main" xmlns:w15="http://schemas.microsoft.com/office/word/2012/wordml" xmlns:w14="http://schemas.microsoft.com/office/word/2010/wordml" xmlns:m="http://schemas.openxmlformats.org/officeDocument/2006/math" xmlns:wp="http://schemas.openxmlformats.org/drawingml/2006/wordprocessingDrawing" xmlns:wp14="http://schemas.microsoft.com/office/word/2010/wordprocessingDrawing" xmlns:mc="http://schemas.openxmlformats.org/markup-compatibility/2006" xmlns:sl="http://schemas.openxmlformats.org/schemaLibrary/2006/main" xmlns:wne="http://schemas.microsoft.com/office/word/2006/wordml" xmlns:cdr="http://schemas.openxmlformats.org/drawingml/2006/chartDrawing" xmlns:c14="http://schemas.microsoft.com/office/drawing/2007/8/2/chart" xmlns:dgm="http://schemas.openxmlformats.org/drawingml/2006/diagram" xmlns:pic="http://schemas.openxmlformats.org/drawingml/2006/picture" xmlns:xdr="http://schemas.openxmlformats.org/drawingml/2006/spreadsheetDrawing" xmlns:dsp="http://schemas.microsoft.com/office/drawing/2008/diagram" xmlns:xvml="urn:schemas-microsoft-com:office:excel" xmlns:o="urn:schemas-microsoft-com:office:office" xmlns:v="urn:schemas-microsoft-com:vml" xmlns:w10="urn:schemas-microsoft-com:office:word" xmlns:pvml="urn:schemas-microsoft-com:office:powerpoint" xmlns:cppr="http://schemas.microsoft.com/office/2006/coverPageProps" xmlns:odx="http://opendope.org/xpaths" xmlns:odc="http://opendope.org/conditions" xmlns:odq="http://opendope.org/questions" xmlns:oda="http://opendope.org/answers" xmlns:odi="http://opendope.org/components" xmlns:odgm="http://opendope.org/SmartArt/DataHierarchy" xmlns:b="http://schemas.openxmlformats.org/officeDocument/2006/bibliography" xmlns:wps="http://schemas.microsoft.com/office/word/2010/wordprocessingShape" xmlns:w16se="http://schemas.microsoft.com/office/word/2015/wordml/symex" xmlns:w16cid="http://schemas.microsoft.com/office/word/2016/wordml/cid" xmlns:wetp="http://schemas.microsoft.com/office/webextensions/taskpanes/2010/11" xmlns:we="http://schemas.microsoft.com/office/webextensions/webextension/2010/11" xmlns:comp="http://schemas.openxmlformats.org/drawingml/2006/compatibility" xmlns:lc="http://schemas.openxmlformats.org/drawingml/2006/lockedCanvas">
             <c:ext xmlns:c16="http://schemas.microsoft.com/office/drawing/2014/chart" uri="{C3380CC4-5D6E-409C-BE32-E72D297353CC}">
               <c16:uniqueId val="{00000001-7C96-CF4F-94AD-E08A5CD6D25E}"/>
             </c:ext>
@@ -601,7 +601,7 @@
     <c:plotVisOnly val="1"/>
     <c:dispBlanksAs val="gap"/>
     <c:showDLblsOverMax val="0"/>
-    <c:extLst xmlns:lc="http://schemas.openxmlformats.org/drawingml/2006/lockedCanvas" xmlns:comp="http://schemas.openxmlformats.org/drawingml/2006/compatibility" xmlns:we="http://schemas.microsoft.com/office/webextensions/webextension/2010/11" xmlns:wetp="http://schemas.microsoft.com/office/webextensions/taskpanes/2010/11" xmlns:w16cid="http://schemas.microsoft.com/office/word/2016/wordml/cid" xmlns:w16se="http://schemas.microsoft.com/office/word/2015/wordml/symex" xmlns:wps="http://schemas.microsoft.com/office/word/2010/wordprocessingShape" xmlns:b="http://schemas.openxmlformats.org/officeDocument/2006/bibliography" xmlns:odgm="http://opendope.org/SmartArt/DataHierarchy" xmlns:odi="http://opendope.org/components" xmlns:oda="http://opendope.org/answers" xmlns:odq="http://opendope.org/questions" xmlns:odc="http://opendope.org/conditions" xmlns:odx="http://opendope.org/xpaths" xmlns:cppr="http://schemas.microsoft.com/office/2006/coverPageProps" xmlns:pvml="urn:schemas-microsoft-com:office:powerpoint" xmlns:w10="urn:schemas-microsoft-com:office:word" xmlns:v="urn:schemas-microsoft-com:vml" xmlns:o="urn:schemas-microsoft-com:office:office" xmlns:xvml="urn:schemas-microsoft-com:office:excel" xmlns:dsp="http://schemas.microsoft.com/office/drawing/2008/diagram" xmlns:xdr="http://schemas.openxmlformats.org/drawingml/2006/spreadsheetDrawing" xmlns:pic="http://schemas.openxmlformats.org/drawingml/2006/picture" xmlns:dgm="http://schemas.openxmlformats.org/drawingml/2006/diagram" xmlns:c14="http://schemas.microsoft.com/office/drawing/2007/8/2/chart" xmlns:cdr="http://schemas.openxmlformats.org/drawingml/2006/chartDrawing" xmlns:wne="http://schemas.microsoft.com/office/word/2006/wordml" xmlns:sl="http://schemas.openxmlformats.org/schemaLibrary/2006/main" xmlns:mc="http://schemas.openxmlformats.org/markup-compatibility/2006" xmlns:wp14="http://schemas.microsoft.com/office/word/2010/wordprocessingDrawing" xmlns:wp="http://schemas.openxmlformats.org/drawingml/2006/wordprocessingDrawing" xmlns:m="http://schemas.openxmlformats.org/officeDocument/2006/math" xmlns:w14="http://schemas.microsoft.com/office/word/2010/wordml" xmlns:w15="http://schemas.microsoft.com/office/word/2012/wordml" xmlns:w="http://schemas.openxmlformats.org/wordprocessingml/2006/main">
+    <c:extLst xmlns:w="http://schemas.openxmlformats.org/wordprocessingml/2006/main" xmlns:w15="http://schemas.microsoft.com/office/word/2012/wordml" xmlns:w14="http://schemas.microsoft.com/office/word/2010/wordml" xmlns:m="http://schemas.openxmlformats.org/officeDocument/2006/math" xmlns:wp="http://schemas.openxmlformats.org/drawingml/2006/wordprocessingDrawing" xmlns:wp14="http://schemas.microsoft.com/office/word/2010/wordprocessingDrawing" xmlns:mc="http://schemas.openxmlformats.org/markup-compatibility/2006" xmlns:sl="http://schemas.openxmlformats.org/schemaLibrary/2006/main" xmlns:wne="http://schemas.microsoft.com/office/word/2006/wordml" xmlns:cdr="http://schemas.openxmlformats.org/drawingml/2006/chartDrawing" xmlns:c14="http://schemas.microsoft.com/office/drawing/2007/8/2/chart" xmlns:dgm="http://schemas.openxmlformats.org/drawingml/2006/diagram" xmlns:pic="http://schemas.openxmlformats.org/drawingml/2006/picture" xmlns:xdr="http://schemas.openxmlformats.org/drawingml/2006/spreadsheetDrawing" xmlns:dsp="http://schemas.microsoft.com/office/drawing/2008/diagram" xmlns:xvml="urn:schemas-microsoft-com:office:excel" xmlns:o="urn:schemas-microsoft-com:office:office" xmlns:v="urn:schemas-microsoft-com:vml" xmlns:w10="urn:schemas-microsoft-com:office:word" xmlns:pvml="urn:schemas-microsoft-com:office:powerpoint" xmlns:cppr="http://schemas.microsoft.com/office/2006/coverPageProps" xmlns:odx="http://opendope.org/xpaths" xmlns:odc="http://opendope.org/conditions" xmlns:odq="http://opendope.org/questions" xmlns:oda="http://opendope.org/answers" xmlns:odi="http://opendope.org/components" xmlns:odgm="http://opendope.org/SmartArt/DataHierarchy" xmlns:b="http://schemas.openxmlformats.org/officeDocument/2006/bibliography" xmlns:wps="http://schemas.microsoft.com/office/word/2010/wordprocessingShape" xmlns:w16se="http://schemas.microsoft.com/office/word/2015/wordml/symex" xmlns:w16cid="http://schemas.microsoft.com/office/word/2016/wordml/cid" xmlns:wetp="http://schemas.microsoft.com/office/webextensions/taskpanes/2010/11" xmlns:we="http://schemas.microsoft.com/office/webextensions/webextension/2010/11" xmlns:comp="http://schemas.openxmlformats.org/drawingml/2006/compatibility" xmlns:lc="http://schemas.openxmlformats.org/drawingml/2006/lockedCanvas">
       <c:ext xmlns:c16r3="http://schemas.microsoft.com/office/drawing/2017/03/chart" uri="{56B9EC1D-385E-4148-901F-78D8002777C0}">
         <c16r3:dataDisplayOptions16>
           <c16r3:dispNaAsBlank val="1"/>
@@ -1050,7 +1050,7 @@
                 </a:outerShdw>
               </a:effectLst>
             </c:spPr>
-            <c:extLst xmlns:w="http://schemas.openxmlformats.org/wordprocessingml/2006/main" xmlns:w15="http://schemas.microsoft.com/office/word/2012/wordml" xmlns:w14="http://schemas.microsoft.com/office/word/2010/wordml" xmlns:m="http://schemas.openxmlformats.org/officeDocument/2006/math" xmlns:wp="http://schemas.openxmlformats.org/drawingml/2006/wordprocessingDrawing" xmlns:wp14="http://schemas.microsoft.com/office/word/2010/wordprocessingDrawing" xmlns:mc="http://schemas.openxmlformats.org/markup-compatibility/2006" xmlns:sl="http://schemas.openxmlformats.org/schemaLibrary/2006/main" xmlns:wne="http://schemas.microsoft.com/office/word/2006/wordml" xmlns:cdr="http://schemas.openxmlformats.org/drawingml/2006/chartDrawing" xmlns:c14="http://schemas.microsoft.com/office/drawing/2007/8/2/chart" xmlns:dgm="http://schemas.openxmlformats.org/drawingml/2006/diagram" xmlns:pic="http://schemas.openxmlformats.org/drawingml/2006/picture" xmlns:xdr="http://schemas.openxmlformats.org/drawingml/2006/spreadsheetDrawing" xmlns:dsp="http://schemas.microsoft.com/office/drawing/2008/diagram" xmlns:xvml="urn:schemas-microsoft-com:office:excel" xmlns:o="urn:schemas-microsoft-com:office:office" xmlns:v="urn:schemas-microsoft-com:vml" xmlns:w10="urn:schemas-microsoft-com:office:word" xmlns:pvml="urn:schemas-microsoft-com:office:powerpoint" xmlns:cppr="http://schemas.microsoft.com/office/2006/coverPageProps" xmlns:odx="http://opendope.org/xpaths" xmlns:odc="http://opendope.org/conditions" xmlns:odq="http://opendope.org/questions" xmlns:oda="http://opendope.org/answers" xmlns:odi="http://opendope.org/components" xmlns:odgm="http://opendope.org/SmartArt/DataHierarchy" xmlns:b="http://schemas.openxmlformats.org/officeDocument/2006/bibliography" xmlns:wps="http://schemas.microsoft.com/office/word/2010/wordprocessingShape" xmlns:w16se="http://schemas.microsoft.com/office/word/2015/wordml/symex" xmlns:w16cid="http://schemas.microsoft.com/office/word/2016/wordml/cid" xmlns:wetp="http://schemas.microsoft.com/office/webextensions/taskpanes/2010/11" xmlns:we="http://schemas.microsoft.com/office/webextensions/webextension/2010/11" xmlns:comp="http://schemas.openxmlformats.org/drawingml/2006/compatibility" xmlns:lc="http://schemas.openxmlformats.org/drawingml/2006/lockedCanvas">
+            <c:extLst xmlns:lc="http://schemas.openxmlformats.org/drawingml/2006/lockedCanvas" xmlns:comp="http://schemas.openxmlformats.org/drawingml/2006/compatibility" xmlns:we="http://schemas.microsoft.com/office/webextensions/webextension/2010/11" xmlns:wetp="http://schemas.microsoft.com/office/webextensions/taskpanes/2010/11" xmlns:w16cid="http://schemas.microsoft.com/office/word/2016/wordml/cid" xmlns:w16se="http://schemas.microsoft.com/office/word/2015/wordml/symex" xmlns:wps="http://schemas.microsoft.com/office/word/2010/wordprocessingShape" xmlns:b="http://schemas.openxmlformats.org/officeDocument/2006/bibliography" xmlns:odgm="http://opendope.org/SmartArt/DataHierarchy" xmlns:odi="http://opendope.org/components" xmlns:oda="http://opendope.org/answers" xmlns:odq="http://opendope.org/questions" xmlns:odc="http://opendope.org/conditions" xmlns:odx="http://opendope.org/xpaths" xmlns:cppr="http://schemas.microsoft.com/office/2006/coverPageProps" xmlns:pvml="urn:schemas-microsoft-com:office:powerpoint" xmlns:w10="urn:schemas-microsoft-com:office:word" xmlns:v="urn:schemas-microsoft-com:vml" xmlns:o="urn:schemas-microsoft-com:office:office" xmlns:xvml="urn:schemas-microsoft-com:office:excel" xmlns:dsp="http://schemas.microsoft.com/office/drawing/2008/diagram" xmlns:xdr="http://schemas.openxmlformats.org/drawingml/2006/spreadsheetDrawing" xmlns:pic="http://schemas.openxmlformats.org/drawingml/2006/picture" xmlns:dgm="http://schemas.openxmlformats.org/drawingml/2006/diagram" xmlns:c14="http://schemas.microsoft.com/office/drawing/2007/8/2/chart" xmlns:cdr="http://schemas.openxmlformats.org/drawingml/2006/chartDrawing" xmlns:wne="http://schemas.microsoft.com/office/word/2006/wordml" xmlns:sl="http://schemas.openxmlformats.org/schemaLibrary/2006/main" xmlns:mc="http://schemas.openxmlformats.org/markup-compatibility/2006" xmlns:wp14="http://schemas.microsoft.com/office/word/2010/wordprocessingDrawing" xmlns:wp="http://schemas.openxmlformats.org/drawingml/2006/wordprocessingDrawing" xmlns:m="http://schemas.openxmlformats.org/officeDocument/2006/math" xmlns:w14="http://schemas.microsoft.com/office/word/2010/wordml" xmlns:w15="http://schemas.microsoft.com/office/word/2012/wordml" xmlns:w="http://schemas.openxmlformats.org/wordprocessingml/2006/main">
               <c:ext xmlns:c16="http://schemas.microsoft.com/office/drawing/2014/chart" uri="{C3380CC4-5D6E-409C-BE32-E72D297353CC}">
                 <c16:uniqueId val="{00000001-6147-E74A-AA7B-5531F0E4EE0C}"/>
               </c:ext>
@@ -1175,7 +1175,7 @@
               </c:numCache>
             </c:numRef>
           </c:val>
-          <c:extLst xmlns:w="http://schemas.openxmlformats.org/wordprocessingml/2006/main" xmlns:w15="http://schemas.microsoft.com/office/word/2012/wordml" xmlns:w14="http://schemas.microsoft.com/office/word/2010/wordml" xmlns:m="http://schemas.openxmlformats.org/officeDocument/2006/math" xmlns:wp="http://schemas.openxmlformats.org/drawingml/2006/wordprocessingDrawing" xmlns:wp14="http://schemas.microsoft.com/office/word/2010/wordprocessingDrawing" xmlns:mc="http://schemas.openxmlformats.org/markup-compatibility/2006" xmlns:sl="http://schemas.openxmlformats.org/schemaLibrary/2006/main" xmlns:wne="http://schemas.microsoft.com/office/word/2006/wordml" xmlns:cdr="http://schemas.openxmlformats.org/drawingml/2006/chartDrawing" xmlns:c14="http://schemas.microsoft.com/office/drawing/2007/8/2/chart" xmlns:dgm="http://schemas.openxmlformats.org/drawingml/2006/diagram" xmlns:pic="http://schemas.openxmlformats.org/drawingml/2006/picture" xmlns:xdr="http://schemas.openxmlformats.org/drawingml/2006/spreadsheetDrawing" xmlns:dsp="http://schemas.microsoft.com/office/drawing/2008/diagram" xmlns:xvml="urn:schemas-microsoft-com:office:excel" xmlns:o="urn:schemas-microsoft-com:office:office" xmlns:v="urn:schemas-microsoft-com:vml" xmlns:w10="urn:schemas-microsoft-com:office:word" xmlns:pvml="urn:schemas-microsoft-com:office:powerpoint" xmlns:cppr="http://schemas.microsoft.com/office/2006/coverPageProps" xmlns:odx="http://opendope.org/xpaths" xmlns:odc="http://opendope.org/conditions" xmlns:odq="http://opendope.org/questions" xmlns:oda="http://opendope.org/answers" xmlns:odi="http://opendope.org/components" xmlns:odgm="http://opendope.org/SmartArt/DataHierarchy" xmlns:b="http://schemas.openxmlformats.org/officeDocument/2006/bibliography" xmlns:wps="http://schemas.microsoft.com/office/word/2010/wordprocessingShape" xmlns:w16se="http://schemas.microsoft.com/office/word/2015/wordml/symex" xmlns:w16cid="http://schemas.microsoft.com/office/word/2016/wordml/cid" xmlns:wetp="http://schemas.microsoft.com/office/webextensions/taskpanes/2010/11" xmlns:we="http://schemas.microsoft.com/office/webextensions/webextension/2010/11" xmlns:comp="http://schemas.openxmlformats.org/drawingml/2006/compatibility" xmlns:lc="http://schemas.openxmlformats.org/drawingml/2006/lockedCanvas">
+          <c:extLst xmlns:lc="http://schemas.openxmlformats.org/drawingml/2006/lockedCanvas" xmlns:comp="http://schemas.openxmlformats.org/drawingml/2006/compatibility" xmlns:we="http://schemas.microsoft.com/office/webextensions/webextension/2010/11" xmlns:wetp="http://schemas.microsoft.com/office/webextensions/taskpanes/2010/11" xmlns:w16cid="http://schemas.microsoft.com/office/word/2016/wordml/cid" xmlns:w16se="http://schemas.microsoft.com/office/word/2015/wordml/symex" xmlns:wps="http://schemas.microsoft.com/office/word/2010/wordprocessingShape" xmlns:b="http://schemas.openxmlformats.org/officeDocument/2006/bibliography" xmlns:odgm="http://opendope.org/SmartArt/DataHierarchy" xmlns:odi="http://opendope.org/components" xmlns:oda="http://opendope.org/answers" xmlns:odq="http://opendope.org/questions" xmlns:odc="http://opendope.org/conditions" xmlns:odx="http://opendope.org/xpaths" xmlns:cppr="http://schemas.microsoft.com/office/2006/coverPageProps" xmlns:pvml="urn:schemas-microsoft-com:office:powerpoint" xmlns:w10="urn:schemas-microsoft-com:office:word" xmlns:v="urn:schemas-microsoft-com:vml" xmlns:o="urn:schemas-microsoft-com:office:office" xmlns:xvml="urn:schemas-microsoft-com:office:excel" xmlns:dsp="http://schemas.microsoft.com/office/drawing/2008/diagram" xmlns:xdr="http://schemas.openxmlformats.org/drawingml/2006/spreadsheetDrawing" xmlns:pic="http://schemas.openxmlformats.org/drawingml/2006/picture" xmlns:dgm="http://schemas.openxmlformats.org/drawingml/2006/diagram" xmlns:c14="http://schemas.microsoft.com/office/drawing/2007/8/2/chart" xmlns:cdr="http://schemas.openxmlformats.org/drawingml/2006/chartDrawing" xmlns:wne="http://schemas.microsoft.com/office/word/2006/wordml" xmlns:sl="http://schemas.openxmlformats.org/schemaLibrary/2006/main" xmlns:mc="http://schemas.openxmlformats.org/markup-compatibility/2006" xmlns:wp14="http://schemas.microsoft.com/office/word/2010/wordprocessingDrawing" xmlns:wp="http://schemas.openxmlformats.org/drawingml/2006/wordprocessingDrawing" xmlns:m="http://schemas.openxmlformats.org/officeDocument/2006/math" xmlns:w14="http://schemas.microsoft.com/office/word/2010/wordml" xmlns:w15="http://schemas.microsoft.com/office/word/2012/wordml" xmlns:w="http://schemas.openxmlformats.org/wordprocessingml/2006/main">
             <c:ext xmlns:c16="http://schemas.microsoft.com/office/drawing/2014/chart" uri="{C3380CC4-5D6E-409C-BE32-E72D297353CC}">
               <c16:uniqueId val="{00000002-6147-E74A-AA7B-5531F0E4EE0C}"/>
             </c:ext>
@@ -1633,7 +1633,7 @@
     <c:plotVisOnly val="1"/>
     <c:dispBlanksAs val="gap"/>
     <c:showDLblsOverMax val="0"/>
-    <c:extLst xmlns:w="http://schemas.openxmlformats.org/wordprocessingml/2006/main" xmlns:w15="http://schemas.microsoft.com/office/word/2012/wordml" xmlns:w14="http://schemas.microsoft.com/office/word/2010/wordml" xmlns:m="http://schemas.openxmlformats.org/officeDocument/2006/math" xmlns:wp="http://schemas.openxmlformats.org/drawingml/2006/wordprocessingDrawing" xmlns:wp14="http://schemas.microsoft.com/office/word/2010/wordprocessingDrawing" xmlns:mc="http://schemas.openxmlformats.org/markup-compatibility/2006" xmlns:sl="http://schemas.openxmlformats.org/schemaLibrary/2006/main" xmlns:wne="http://schemas.microsoft.com/office/word/2006/wordml" xmlns:cdr="http://schemas.openxmlformats.org/drawingml/2006/chartDrawing" xmlns:c14="http://schemas.microsoft.com/office/drawing/2007/8/2/chart" xmlns:dgm="http://schemas.openxmlformats.org/drawingml/2006/diagram" xmlns:pic="http://schemas.openxmlformats.org/drawingml/2006/picture" xmlns:xdr="http://schemas.openxmlformats.org/drawingml/2006/spreadsheetDrawing" xmlns:dsp="http://schemas.microsoft.com/office/drawing/2008/diagram" xmlns:xvml="urn:schemas-microsoft-com:office:excel" xmlns:o="urn:schemas-microsoft-com:office:office" xmlns:v="urn:schemas-microsoft-com:vml" xmlns:w10="urn:schemas-microsoft-com:office:word" xmlns:pvml="urn:schemas-microsoft-com:office:powerpoint" xmlns:cppr="http://schemas.microsoft.com/office/2006/coverPageProps" xmlns:odx="http://opendope.org/xpaths" xmlns:odc="http://opendope.org/conditions" xmlns:odq="http://opendope.org/questions" xmlns:oda="http://opendope.org/answers" xmlns:odi="http://opendope.org/components" xmlns:odgm="http://opendope.org/SmartArt/DataHierarchy" xmlns:b="http://schemas.openxmlformats.org/officeDocument/2006/bibliography" xmlns:wps="http://schemas.microsoft.com/office/word/2010/wordprocessingShape" xmlns:w16se="http://schemas.microsoft.com/office/word/2015/wordml/symex" xmlns:w16cid="http://schemas.microsoft.com/office/word/2016/wordml/cid" xmlns:wetp="http://schemas.microsoft.com/office/webextensions/taskpanes/2010/11" xmlns:we="http://schemas.microsoft.com/office/webextensions/webextension/2010/11" xmlns:comp="http://schemas.openxmlformats.org/drawingml/2006/compatibility" xmlns:lc="http://schemas.openxmlformats.org/drawingml/2006/lockedCanvas">
+    <c:extLst xmlns:lc="http://schemas.openxmlformats.org/drawingml/2006/lockedCanvas" xmlns:comp="http://schemas.openxmlformats.org/drawingml/2006/compatibility" xmlns:we="http://schemas.microsoft.com/office/webextensions/webextension/2010/11" xmlns:wetp="http://schemas.microsoft.com/office/webextensions/taskpanes/2010/11" xmlns:w16cid="http://schemas.microsoft.com/office/word/2016/wordml/cid" xmlns:w16se="http://schemas.microsoft.com/office/word/2015/wordml/symex" xmlns:wps="http://schemas.microsoft.com/office/word/2010/wordprocessingShape" xmlns:b="http://schemas.openxmlformats.org/officeDocument/2006/bibliography" xmlns:odgm="http://opendope.org/SmartArt/DataHierarchy" xmlns:odi="http://opendope.org/components" xmlns:oda="http://opendope.org/answers" xmlns:odq="http://opendope.org/questions" xmlns:odc="http://opendope.org/conditions" xmlns:odx="http://opendope.org/xpaths" xmlns:cppr="http://schemas.microsoft.com/office/2006/coverPageProps" xmlns:pvml="urn:schemas-microsoft-com:office:powerpoint" xmlns:w10="urn:schemas-microsoft-com:office:word" xmlns:v="urn:schemas-microsoft-com:vml" xmlns:o="urn:schemas-microsoft-com:office:office" xmlns:xvml="urn:schemas-microsoft-com:office:excel" xmlns:dsp="http://schemas.microsoft.com/office/drawing/2008/diagram" xmlns:xdr="http://schemas.openxmlformats.org/drawingml/2006/spreadsheetDrawing" xmlns:pic="http://schemas.openxmlformats.org/drawingml/2006/picture" xmlns:dgm="http://schemas.openxmlformats.org/drawingml/2006/diagram" xmlns:c14="http://schemas.microsoft.com/office/drawing/2007/8/2/chart" xmlns:cdr="http://schemas.openxmlformats.org/drawingml/2006/chartDrawing" xmlns:wne="http://schemas.microsoft.com/office/word/2006/wordml" xmlns:sl="http://schemas.openxmlformats.org/schemaLibrary/2006/main" xmlns:mc="http://schemas.openxmlformats.org/markup-compatibility/2006" xmlns:wp14="http://schemas.microsoft.com/office/word/2010/wordprocessingDrawing" xmlns:wp="http://schemas.openxmlformats.org/drawingml/2006/wordprocessingDrawing" xmlns:m="http://schemas.openxmlformats.org/officeDocument/2006/math" xmlns:w14="http://schemas.microsoft.com/office/word/2010/wordml" xmlns:w15="http://schemas.microsoft.com/office/word/2012/wordml" xmlns:w="http://schemas.openxmlformats.org/wordprocessingml/2006/main">
       <c:ext xmlns:c16r3="http://schemas.microsoft.com/office/drawing/2017/03/chart" uri="{56B9EC1D-385E-4148-901F-78D8002777C0}">
         <c16r3:dataDisplayOptions16>
           <c16r3:dispNaAsBlank val="1"/>
@@ -1735,7 +1735,7 @@
                 </a:outerShdw>
               </a:effectLst>
             </c:spPr>
-            <c:extLst xmlns:w="http://schemas.openxmlformats.org/wordprocessingml/2006/main" xmlns:w15="http://schemas.microsoft.com/office/word/2012/wordml" xmlns:w14="http://schemas.microsoft.com/office/word/2010/wordml" xmlns:m="http://schemas.openxmlformats.org/officeDocument/2006/math" xmlns:wp="http://schemas.openxmlformats.org/drawingml/2006/wordprocessingDrawing" xmlns:wp14="http://schemas.microsoft.com/office/word/2010/wordprocessingDrawing" xmlns:mc="http://schemas.openxmlformats.org/markup-compatibility/2006" xmlns:sl="http://schemas.openxmlformats.org/schemaLibrary/2006/main" xmlns:wne="http://schemas.microsoft.com/office/word/2006/wordml" xmlns:cdr="http://schemas.openxmlformats.org/drawingml/2006/chartDrawing" xmlns:c14="http://schemas.microsoft.com/office/drawing/2007/8/2/chart" xmlns:dgm="http://schemas.openxmlformats.org/drawingml/2006/diagram" xmlns:pic="http://schemas.openxmlformats.org/drawingml/2006/picture" xmlns:xdr="http://schemas.openxmlformats.org/drawingml/2006/spreadsheetDrawing" xmlns:dsp="http://schemas.microsoft.com/office/drawing/2008/diagram" xmlns:xvml="urn:schemas-microsoft-com:office:excel" xmlns:o="urn:schemas-microsoft-com:office:office" xmlns:v="urn:schemas-microsoft-com:vml" xmlns:w10="urn:schemas-microsoft-com:office:word" xmlns:pvml="urn:schemas-microsoft-com:office:powerpoint" xmlns:cppr="http://schemas.microsoft.com/office/2006/coverPageProps" xmlns:odx="http://opendope.org/xpaths" xmlns:odc="http://opendope.org/conditions" xmlns:odq="http://opendope.org/questions" xmlns:oda="http://opendope.org/answers" xmlns:odi="http://opendope.org/components" xmlns:odgm="http://opendope.org/SmartArt/DataHierarchy" xmlns:b="http://schemas.openxmlformats.org/officeDocument/2006/bibliography" xmlns:wps="http://schemas.microsoft.com/office/word/2010/wordprocessingShape" xmlns:w16se="http://schemas.microsoft.com/office/word/2015/wordml/symex" xmlns:w16cid="http://schemas.microsoft.com/office/word/2016/wordml/cid" xmlns:wetp="http://schemas.microsoft.com/office/webextensions/taskpanes/2010/11" xmlns:we="http://schemas.microsoft.com/office/webextensions/webextension/2010/11" xmlns:comp="http://schemas.openxmlformats.org/drawingml/2006/compatibility" xmlns:lc="http://schemas.openxmlformats.org/drawingml/2006/lockedCanvas">
+            <c:extLst xmlns:lc="http://schemas.openxmlformats.org/drawingml/2006/lockedCanvas" xmlns:comp="http://schemas.openxmlformats.org/drawingml/2006/compatibility" xmlns:we="http://schemas.microsoft.com/office/webextensions/webextension/2010/11" xmlns:wetp="http://schemas.microsoft.com/office/webextensions/taskpanes/2010/11" xmlns:w16cid="http://schemas.microsoft.com/office/word/2016/wordml/cid" xmlns:w16se="http://schemas.microsoft.com/office/word/2015/wordml/symex" xmlns:wps="http://schemas.microsoft.com/office/word/2010/wordprocessingShape" xmlns:b="http://schemas.openxmlformats.org/officeDocument/2006/bibliography" xmlns:odgm="http://opendope.org/SmartArt/DataHierarchy" xmlns:odi="http://opendope.org/components" xmlns:oda="http://opendope.org/answers" xmlns:odq="http://opendope.org/questions" xmlns:odc="http://opendope.org/conditions" xmlns:odx="http://opendope.org/xpaths" xmlns:cppr="http://schemas.microsoft.com/office/2006/coverPageProps" xmlns:pvml="urn:schemas-microsoft-com:office:powerpoint" xmlns:w10="urn:schemas-microsoft-com:office:word" xmlns:v="urn:schemas-microsoft-com:vml" xmlns:o="urn:schemas-microsoft-com:office:office" xmlns:xvml="urn:schemas-microsoft-com:office:excel" xmlns:dsp="http://schemas.microsoft.com/office/drawing/2008/diagram" xmlns:xdr="http://schemas.openxmlformats.org/drawingml/2006/spreadsheetDrawing" xmlns:pic="http://schemas.openxmlformats.org/drawingml/2006/picture" xmlns:dgm="http://schemas.openxmlformats.org/drawingml/2006/diagram" xmlns:c14="http://schemas.microsoft.com/office/drawing/2007/8/2/chart" xmlns:cdr="http://schemas.openxmlformats.org/drawingml/2006/chartDrawing" xmlns:wne="http://schemas.microsoft.com/office/word/2006/wordml" xmlns:sl="http://schemas.openxmlformats.org/schemaLibrary/2006/main" xmlns:mc="http://schemas.openxmlformats.org/markup-compatibility/2006" xmlns:wp14="http://schemas.microsoft.com/office/word/2010/wordprocessingDrawing" xmlns:wp="http://schemas.openxmlformats.org/drawingml/2006/wordprocessingDrawing" xmlns:m="http://schemas.openxmlformats.org/officeDocument/2006/math" xmlns:w14="http://schemas.microsoft.com/office/word/2010/wordml" xmlns:w15="http://schemas.microsoft.com/office/word/2012/wordml" xmlns:w="http://schemas.openxmlformats.org/wordprocessingml/2006/main">
               <c:ext xmlns:c16="http://schemas.microsoft.com/office/drawing/2014/chart" uri="{C3380CC4-5D6E-409C-BE32-E72D297353CC}">
                 <c16:uniqueId val="{00000001-6147-E74A-AA7B-5531F0E4EE0C}"/>
               </c:ext>
@@ -1838,7 +1838,7 @@
               </c:numCache>
             </c:numRef>
           </c:val>
-          <c:extLst xmlns:w="http://schemas.openxmlformats.org/wordprocessingml/2006/main" xmlns:w15="http://schemas.microsoft.com/office/word/2012/wordml" xmlns:w14="http://schemas.microsoft.com/office/word/2010/wordml" xmlns:m="http://schemas.openxmlformats.org/officeDocument/2006/math" xmlns:wp="http://schemas.openxmlformats.org/drawingml/2006/wordprocessingDrawing" xmlns:wp14="http://schemas.microsoft.com/office/word/2010/wordprocessingDrawing" xmlns:mc="http://schemas.openxmlformats.org/markup-compatibility/2006" xmlns:sl="http://schemas.openxmlformats.org/schemaLibrary/2006/main" xmlns:wne="http://schemas.microsoft.com/office/word/2006/wordml" xmlns:cdr="http://schemas.openxmlformats.org/drawingml/2006/chartDrawing" xmlns:c14="http://schemas.microsoft.com/office/drawing/2007/8/2/chart" xmlns:dgm="http://schemas.openxmlformats.org/drawingml/2006/diagram" xmlns:pic="http://schemas.openxmlformats.org/drawingml/2006/picture" xmlns:xdr="http://schemas.openxmlformats.org/drawingml/2006/spreadsheetDrawing" xmlns:dsp="http://schemas.microsoft.com/office/drawing/2008/diagram" xmlns:xvml="urn:schemas-microsoft-com:office:excel" xmlns:o="urn:schemas-microsoft-com:office:office" xmlns:v="urn:schemas-microsoft-com:vml" xmlns:w10="urn:schemas-microsoft-com:office:word" xmlns:pvml="urn:schemas-microsoft-com:office:powerpoint" xmlns:cppr="http://schemas.microsoft.com/office/2006/coverPageProps" xmlns:odx="http://opendope.org/xpaths" xmlns:odc="http://opendope.org/conditions" xmlns:odq="http://opendope.org/questions" xmlns:oda="http://opendope.org/answers" xmlns:odi="http://opendope.org/components" xmlns:odgm="http://opendope.org/SmartArt/DataHierarchy" xmlns:b="http://schemas.openxmlformats.org/officeDocument/2006/bibliography" xmlns:wps="http://schemas.microsoft.com/office/word/2010/wordprocessingShape" xmlns:w16se="http://schemas.microsoft.com/office/word/2015/wordml/symex" xmlns:w16cid="http://schemas.microsoft.com/office/word/2016/wordml/cid" xmlns:wetp="http://schemas.microsoft.com/office/webextensions/taskpanes/2010/11" xmlns:we="http://schemas.microsoft.com/office/webextensions/webextension/2010/11" xmlns:comp="http://schemas.openxmlformats.org/drawingml/2006/compatibility" xmlns:lc="http://schemas.openxmlformats.org/drawingml/2006/lockedCanvas">
+          <c:extLst xmlns:lc="http://schemas.openxmlformats.org/drawingml/2006/lockedCanvas" xmlns:comp="http://schemas.openxmlformats.org/drawingml/2006/compatibility" xmlns:we="http://schemas.microsoft.com/office/webextensions/webextension/2010/11" xmlns:wetp="http://schemas.microsoft.com/office/webextensions/taskpanes/2010/11" xmlns:w16cid="http://schemas.microsoft.com/office/word/2016/wordml/cid" xmlns:w16se="http://schemas.microsoft.com/office/word/2015/wordml/symex" xmlns:wps="http://schemas.microsoft.com/office/word/2010/wordprocessingShape" xmlns:b="http://schemas.openxmlformats.org/officeDocument/2006/bibliography" xmlns:odgm="http://opendope.org/SmartArt/DataHierarchy" xmlns:odi="http://opendope.org/components" xmlns:oda="http://opendope.org/answers" xmlns:odq="http://opendope.org/questions" xmlns:odc="http://opendope.org/conditions" xmlns:odx="http://opendope.org/xpaths" xmlns:cppr="http://schemas.microsoft.com/office/2006/coverPageProps" xmlns:pvml="urn:schemas-microsoft-com:office:powerpoint" xmlns:w10="urn:schemas-microsoft-com:office:word" xmlns:v="urn:schemas-microsoft-com:vml" xmlns:o="urn:schemas-microsoft-com:office:office" xmlns:xvml="urn:schemas-microsoft-com:office:excel" xmlns:dsp="http://schemas.microsoft.com/office/drawing/2008/diagram" xmlns:xdr="http://schemas.openxmlformats.org/drawingml/2006/spreadsheetDrawing" xmlns:pic="http://schemas.openxmlformats.org/drawingml/2006/picture" xmlns:dgm="http://schemas.openxmlformats.org/drawingml/2006/diagram" xmlns:c14="http://schemas.microsoft.com/office/drawing/2007/8/2/chart" xmlns:cdr="http://schemas.openxmlformats.org/drawingml/2006/chartDrawing" xmlns:wne="http://schemas.microsoft.com/office/word/2006/wordml" xmlns:sl="http://schemas.openxmlformats.org/schemaLibrary/2006/main" xmlns:mc="http://schemas.openxmlformats.org/markup-compatibility/2006" xmlns:wp14="http://schemas.microsoft.com/office/word/2010/wordprocessingDrawing" xmlns:wp="http://schemas.openxmlformats.org/drawingml/2006/wordprocessingDrawing" xmlns:m="http://schemas.openxmlformats.org/officeDocument/2006/math" xmlns:w14="http://schemas.microsoft.com/office/word/2010/wordml" xmlns:w15="http://schemas.microsoft.com/office/word/2012/wordml" xmlns:w="http://schemas.openxmlformats.org/wordprocessingml/2006/main">
             <c:ext xmlns:c16="http://schemas.microsoft.com/office/drawing/2014/chart" uri="{C3380CC4-5D6E-409C-BE32-E72D297353CC}">
               <c16:uniqueId val="{00000002-6147-E74A-AA7B-5531F0E4EE0C}"/>
             </c:ext>
@@ -2296,7 +2296,7 @@
     <c:plotVisOnly val="1"/>
     <c:dispBlanksAs val="gap"/>
     <c:showDLblsOverMax val="0"/>
-    <c:extLst xmlns:w="http://schemas.openxmlformats.org/wordprocessingml/2006/main" xmlns:w15="http://schemas.microsoft.com/office/word/2012/wordml" xmlns:w14="http://schemas.microsoft.com/office/word/2010/wordml" xmlns:m="http://schemas.openxmlformats.org/officeDocument/2006/math" xmlns:wp="http://schemas.openxmlformats.org/drawingml/2006/wordprocessingDrawing" xmlns:wp14="http://schemas.microsoft.com/office/word/2010/wordprocessingDrawing" xmlns:mc="http://schemas.openxmlformats.org/markup-compatibility/2006" xmlns:sl="http://schemas.openxmlformats.org/schemaLibrary/2006/main" xmlns:wne="http://schemas.microsoft.com/office/word/2006/wordml" xmlns:cdr="http://schemas.openxmlformats.org/drawingml/2006/chartDrawing" xmlns:c14="http://schemas.microsoft.com/office/drawing/2007/8/2/chart" xmlns:dgm="http://schemas.openxmlformats.org/drawingml/2006/diagram" xmlns:pic="http://schemas.openxmlformats.org/drawingml/2006/picture" xmlns:xdr="http://schemas.openxmlformats.org/drawingml/2006/spreadsheetDrawing" xmlns:dsp="http://schemas.microsoft.com/office/drawing/2008/diagram" xmlns:xvml="urn:schemas-microsoft-com:office:excel" xmlns:o="urn:schemas-microsoft-com:office:office" xmlns:v="urn:schemas-microsoft-com:vml" xmlns:w10="urn:schemas-microsoft-com:office:word" xmlns:pvml="urn:schemas-microsoft-com:office:powerpoint" xmlns:cppr="http://schemas.microsoft.com/office/2006/coverPageProps" xmlns:odx="http://opendope.org/xpaths" xmlns:odc="http://opendope.org/conditions" xmlns:odq="http://opendope.org/questions" xmlns:oda="http://opendope.org/answers" xmlns:odi="http://opendope.org/components" xmlns:odgm="http://opendope.org/SmartArt/DataHierarchy" xmlns:b="http://schemas.openxmlformats.org/officeDocument/2006/bibliography" xmlns:wps="http://schemas.microsoft.com/office/word/2010/wordprocessingShape" xmlns:w16se="http://schemas.microsoft.com/office/word/2015/wordml/symex" xmlns:w16cid="http://schemas.microsoft.com/office/word/2016/wordml/cid" xmlns:wetp="http://schemas.microsoft.com/office/webextensions/taskpanes/2010/11" xmlns:we="http://schemas.microsoft.com/office/webextensions/webextension/2010/11" xmlns:comp="http://schemas.openxmlformats.org/drawingml/2006/compatibility" xmlns:lc="http://schemas.openxmlformats.org/drawingml/2006/lockedCanvas">
+    <c:extLst xmlns:lc="http://schemas.openxmlformats.org/drawingml/2006/lockedCanvas" xmlns:comp="http://schemas.openxmlformats.org/drawingml/2006/compatibility" xmlns:we="http://schemas.microsoft.com/office/webextensions/webextension/2010/11" xmlns:wetp="http://schemas.microsoft.com/office/webextensions/taskpanes/2010/11" xmlns:w16cid="http://schemas.microsoft.com/office/word/2016/wordml/cid" xmlns:w16se="http://schemas.microsoft.com/office/word/2015/wordml/symex" xmlns:wps="http://schemas.microsoft.com/office/word/2010/wordprocessingShape" xmlns:b="http://schemas.openxmlformats.org/officeDocument/2006/bibliography" xmlns:odgm="http://opendope.org/SmartArt/DataHierarchy" xmlns:odi="http://opendope.org/components" xmlns:oda="http://opendope.org/answers" xmlns:odq="http://opendope.org/questions" xmlns:odc="http://opendope.org/conditions" xmlns:odx="http://opendope.org/xpaths" xmlns:cppr="http://schemas.microsoft.com/office/2006/coverPageProps" xmlns:pvml="urn:schemas-microsoft-com:office:powerpoint" xmlns:w10="urn:schemas-microsoft-com:office:word" xmlns:v="urn:schemas-microsoft-com:vml" xmlns:o="urn:schemas-microsoft-com:office:office" xmlns:xvml="urn:schemas-microsoft-com:office:excel" xmlns:dsp="http://schemas.microsoft.com/office/drawing/2008/diagram" xmlns:xdr="http://schemas.openxmlformats.org/drawingml/2006/spreadsheetDrawing" xmlns:pic="http://schemas.openxmlformats.org/drawingml/2006/picture" xmlns:dgm="http://schemas.openxmlformats.org/drawingml/2006/diagram" xmlns:c14="http://schemas.microsoft.com/office/drawing/2007/8/2/chart" xmlns:cdr="http://schemas.openxmlformats.org/drawingml/2006/chartDrawing" xmlns:wne="http://schemas.microsoft.com/office/word/2006/wordml" xmlns:sl="http://schemas.openxmlformats.org/schemaLibrary/2006/main" xmlns:mc="http://schemas.openxmlformats.org/markup-compatibility/2006" xmlns:wp14="http://schemas.microsoft.com/office/word/2010/wordprocessingDrawing" xmlns:wp="http://schemas.openxmlformats.org/drawingml/2006/wordprocessingDrawing" xmlns:m="http://schemas.openxmlformats.org/officeDocument/2006/math" xmlns:w14="http://schemas.microsoft.com/office/word/2010/wordml" xmlns:w15="http://schemas.microsoft.com/office/word/2012/wordml" xmlns:w="http://schemas.openxmlformats.org/wordprocessingml/2006/main">
       <c:ext xmlns:c16r3="http://schemas.microsoft.com/office/drawing/2017/03/chart" uri="{56B9EC1D-385E-4148-901F-78D8002777C0}">
         <c16r3:dataDisplayOptions16>
           <c16r3:dispNaAsBlank val="1"/>
@@ -8110,7 +8110,7 @@
           <a:p>
             <a:fld id="{C1255C68-584F-174D-BB81-51BF91708794}" type="datetimeFigureOut">
               <a:rPr lang="en-US" smtClean="0"/>
-              <a:t>5/6/26</a:t>
+              <a:t>5/7/26</a:t>
             </a:fld>
             <a:endParaRPr lang="en-US"/>
           </a:p>
@@ -8303,7 +8303,7 @@
           <a:p>
             <a:fld id="{A1EDAAC4-819D-C544-9EA1-C73624CFD70B}" type="datetimeFigureOut">
               <a:rPr lang="en-US" smtClean="0"/>
-              <a:t>5/6/26</a:t>
+              <a:t>5/7/26</a:t>
             </a:fld>
             <a:endParaRPr lang="en-US"/>
           </a:p>
@@ -28076,7 +28076,7 @@
         <p:spPr>
           <a:xfrm>
             <a:off x="381600" y="129568"/>
-            <a:ext cx="4192668" cy="228209"/>
+            <a:ext cx="3012217" cy="228209"/>
           </a:xfrm>
         </p:spPr>
         <p:txBody>
@@ -28085,7 +28085,7 @@
           <a:p>
             <a:r>
               <a:rPr lang="en-GB" dirty="0"/>
-              <a:t>Portfolio trends – Test-to-production code ratio</a:t>
+              <a:t>Portfolio trends – Maintainability</a:t>
             </a:r>
           </a:p>
         </p:txBody>
@@ -31701,8 +31701,8 @@
         </p:nvSpPr>
         <p:spPr>
           <a:xfrm>
-            <a:off x="381600" y="129600"/>
-            <a:ext cx="2927899" cy="228145"/>
+            <a:off x="381600" y="129568"/>
+            <a:ext cx="3265171" cy="228209"/>
           </a:xfrm>
         </p:spPr>
         <p:txBody>
@@ -31711,7 +31711,7 @@
           <a:p>
             <a:r>
               <a:rPr lang="en-GB" dirty="0"/>
-              <a:t>Key findings – Open Source and IP</a:t>
+              <a:t>Portfolio trends – Open-Source Health</a:t>
             </a:r>
           </a:p>
         </p:txBody>
@@ -33232,8 +33232,8 @@
         </p:nvSpPr>
         <p:spPr>
           <a:xfrm>
-            <a:off x="381600" y="129600"/>
-            <a:ext cx="735632" cy="228145"/>
+            <a:off x="381600" y="129568"/>
+            <a:ext cx="1325858" cy="228209"/>
           </a:xfrm>
         </p:spPr>
         <p:txBody>
@@ -33246,7 +33246,7 @@
                   <a:schemeClr val="tx2"/>
                 </a:solidFill>
               </a:rPr>
-              <a:t>Context</a:t>
+              <a:t>Report context</a:t>
             </a:r>
             <a:endParaRPr lang="en-GB" dirty="0"/>
           </a:p>
@@ -33474,7 +33474,7 @@
           <a:p>
             <a:r>
               <a:rPr lang="en-GB" dirty="0"/>
-              <a:t>Report Context</a:t>
+              <a:t>Introduction to the baseline report</a:t>
             </a:r>
           </a:p>
         </p:txBody>
@@ -33852,7 +33852,7 @@
         <p:spPr>
           <a:xfrm>
             <a:off x="381600" y="129568"/>
-            <a:ext cx="1916084" cy="228209"/>
+            <a:ext cx="2169037" cy="228209"/>
           </a:xfrm>
         </p:spPr>
         <p:txBody>
@@ -33861,7 +33861,7 @@
           <a:p>
             <a:r>
               <a:rPr lang="en-GB" dirty="0"/>
-              <a:t>Metadata completeness</a:t>
+              <a:t>Sigrid portfolio hygiene</a:t>
             </a:r>
           </a:p>
         </p:txBody>
@@ -34104,7 +34104,7 @@
         <p:spPr>
           <a:xfrm>
             <a:off x="381600" y="129568"/>
-            <a:ext cx="1747448" cy="228209"/>
+            <a:ext cx="2169037" cy="228209"/>
           </a:xfrm>
         </p:spPr>
         <p:txBody>
@@ -34113,7 +34113,7 @@
           <a:p>
             <a:r>
               <a:rPr lang="en-US" dirty="0"/>
-              <a:t>Objectives coverage</a:t>
+              <a:t>Sigrid portfolio hygiene</a:t>
             </a:r>
           </a:p>
         </p:txBody>
@@ -34834,7 +34834,7 @@
         <p:spPr>
           <a:xfrm>
             <a:off x="381600" y="129568"/>
-            <a:ext cx="1747448" cy="228209"/>
+            <a:ext cx="988586" cy="228209"/>
           </a:xfrm>
         </p:spPr>
         <p:txBody>
@@ -34843,7 +34843,7 @@
           <a:p>
             <a:r>
               <a:rPr lang="en-GB" dirty="0"/>
-              <a:t>Objectives - Status</a:t>
+              <a:t>Objectives</a:t>
             </a:r>
           </a:p>
         </p:txBody>
@@ -35160,7 +35160,7 @@
         <p:spPr>
           <a:xfrm>
             <a:off x="381600" y="129568"/>
-            <a:ext cx="1747448" cy="228209"/>
+            <a:ext cx="988586" cy="228209"/>
           </a:xfrm>
         </p:spPr>
         <p:txBody>
@@ -35169,7 +35169,7 @@
           <a:p>
             <a:r>
               <a:rPr lang="en-GB" dirty="0"/>
-              <a:t>Objectives - Status</a:t>
+              <a:t>Objectives</a:t>
             </a:r>
           </a:p>
         </p:txBody>
@@ -36636,18 +36636,18 @@
 </file>
 
 <file path=customXml/item1.xml><?xml version="1.0" encoding="utf-8"?>
-<p:properties xmlns:p="http://schemas.microsoft.com/office/2006/metadata/properties" xmlns:xsi="http://www.w3.org/2001/XMLSchema-instance" xmlns:pc="http://schemas.microsoft.com/office/infopath/2007/PartnerControls">
-  <documentManagement/>
-</p:properties>
-</file>
-
-<file path=customXml/item2.xml><?xml version="1.0" encoding="utf-8"?>
 <?mso-contentType ?>
 <FormTemplates xmlns="http://schemas.microsoft.com/sharepoint/v3/contenttype/forms">
   <Display>DocumentLibraryForm</Display>
   <Edit>DocumentLibraryForm</Edit>
   <New>DocumentLibraryForm</New>
 </FormTemplates>
+</file>
+
+<file path=customXml/item2.xml><?xml version="1.0" encoding="utf-8"?>
+<p:properties xmlns:p="http://schemas.microsoft.com/office/2006/metadata/properties" xmlns:xsi="http://www.w3.org/2001/XMLSchema-instance" xmlns:pc="http://schemas.microsoft.com/office/infopath/2007/PartnerControls">
+  <documentManagement/>
+</p:properties>
 </file>
 
 <file path=customXml/item3.xml><?xml version="1.0" encoding="utf-8"?>
@@ -36789,6 +36789,14 @@
 </file>
 
 <file path=customXml/itemProps1.xml><?xml version="1.0" encoding="utf-8"?>
+<ds:datastoreItem xmlns:ds="http://schemas.openxmlformats.org/officeDocument/2006/customXml" ds:itemID="{88AD9160-B56A-4FCD-857D-8AE63521E7FB}">
+  <ds:schemaRefs>
+    <ds:schemaRef ds:uri="http://schemas.microsoft.com/sharepoint/v3/contenttype/forms"/>
+  </ds:schemaRefs>
+</ds:datastoreItem>
+</file>
+
+<file path=customXml/itemProps2.xml><?xml version="1.0" encoding="utf-8"?>
 <ds:datastoreItem xmlns:ds="http://schemas.openxmlformats.org/officeDocument/2006/customXml" ds:itemID="{7575A4A2-8818-4F4B-AD30-88D568004514}">
   <ds:schemaRefs>
     <ds:schemaRef ds:uri="http://schemas.microsoft.com/office/2006/metadata/properties"/>
@@ -36800,14 +36808,6 @@
     <ds:schemaRef ds:uri="http://schemas.openxmlformats.org/package/2006/metadata/core-properties"/>
     <ds:schemaRef ds:uri="http://www.w3.org/XML/1998/namespace"/>
     <ds:schemaRef ds:uri="http://purl.org/dc/dcmitype/"/>
-  </ds:schemaRefs>
-</ds:datastoreItem>
-</file>
-
-<file path=customXml/itemProps2.xml><?xml version="1.0" encoding="utf-8"?>
-<ds:datastoreItem xmlns:ds="http://schemas.openxmlformats.org/officeDocument/2006/customXml" ds:itemID="{88AD9160-B56A-4FCD-857D-8AE63521E7FB}">
-  <ds:schemaRefs>
-    <ds:schemaRef ds:uri="http://schemas.microsoft.com/sharepoint/v3/contenttype/forms"/>
   </ds:schemaRefs>
 </ds:datastoreItem>
 </file>

</xml_diff>